<commit_message>
Refactor and update speaking portfolio shorts and outlines
- Renamed "Cry Me a Free Tier" to "Buy Me a Free Tier" across multiple shorts.
- Added new short "Minority Report, With Terminals" to the portfolio.
- Updated various shorts to reflect changes in parent outlines and slide references.
- Revised content in several shorts for clarity and accuracy, including adjustments to beats and hooks.
- Enhanced the sync-talks script to count source slides from outlines, improving the accuracy of exported PPTX slide counts.
- Made minor edits to improve the overall coherence and flow of the content.
</commit_message>
<xml_diff>
--- a/artifacts/speaking-portfolio-expanded/decks/dynamic-scaling-15min-handout.pptx
+++ b/artifacts/speaking-portfolio-expanded/decks/dynamic-scaling-15min-handout.pptx
@@ -1591,53 +1591,53 @@
                 <a:ea typeface="Arial"/>
                 <a:cs typeface="Arial"/>
               </a:rPr>
-              <a:t xml:space="preserve">For twenty years scaling was an infra question answered once for everyone. Add replicas or buy a bigger box, then let an autoscaler watch CPU and guess. The workload never got a vote.</a:t>
-            </a:r>
-            <a:endParaRPr lang="en-US" sz="1200"/>
-          </a:p>
-          <a:p>
-            <a:pPr marL="0" indent="0">
-              <a:lnSpc>
-                <a:spcPts val="1560"/>
-              </a:lnSpc>
-              <a:spcAft>
-                <a:spcPts val="0"/>
-              </a:spcAft>
-              <a:buNone/>
-            </a:pPr>
-            <a:r>
-              <a:rPr lang="en-US" sz="1200" b="0">
-                <a:solidFill>
-                  <a:srgbClr val="202b33"/>
-                </a:solidFill>
-                <a:latin typeface="Arial"/>
-                <a:ea typeface="Arial"/>
-                <a:cs typeface="Arial"/>
-              </a:rPr>
-              <a:t xml:space="preserve"/>
-            </a:r>
-            <a:endParaRPr lang="en-US" sz="1200"/>
-          </a:p>
-          <a:p>
-            <a:pPr marL="0" indent="0">
-              <a:lnSpc>
-                <a:spcPts val="1560"/>
-              </a:lnSpc>
-              <a:spcAft>
-                <a:spcPts val="0"/>
-              </a:spcAft>
-              <a:buNone/>
-            </a:pPr>
-            <a:r>
-              <a:rPr lang="en-US" sz="1200" b="0">
-                <a:solidFill>
-                  <a:srgbClr val="202b33"/>
-                </a:solidFill>
-                <a:latin typeface="Arial"/>
-                <a:ea typeface="Arial"/>
-                <a:cs typeface="Arial"/>
-              </a:rPr>
-              <a:t xml:space="preserve">Agentic workloads can vote. The orchestrator knows this batch is mostly waiting on a provider, that this one needs a GPU for ninety seconds, that this one is untrusted code and wants a sandbox. It can say so, per job, at the moment the job starts.</a:t>
+              <a:t xml:space="preserve">For twenty years scaling was an infra question answered once for everyone. Add replicas or buy a bigger box, then let an autoscaler watch CPU and guess. The workload never got a say.</a:t>
+            </a:r>
+            <a:endParaRPr lang="en-US" sz="1200"/>
+          </a:p>
+          <a:p>
+            <a:pPr marL="0" indent="0">
+              <a:lnSpc>
+                <a:spcPts val="1560"/>
+              </a:lnSpc>
+              <a:spcAft>
+                <a:spcPts val="0"/>
+              </a:spcAft>
+              <a:buNone/>
+            </a:pPr>
+            <a:r>
+              <a:rPr lang="en-US" sz="1200" b="0">
+                <a:solidFill>
+                  <a:srgbClr val="202b33"/>
+                </a:solidFill>
+                <a:latin typeface="Arial"/>
+                <a:ea typeface="Arial"/>
+                <a:cs typeface="Arial"/>
+              </a:rPr>
+              <a:t xml:space="preserve"/>
+            </a:r>
+            <a:endParaRPr lang="en-US" sz="1200"/>
+          </a:p>
+          <a:p>
+            <a:pPr marL="0" indent="0">
+              <a:lnSpc>
+                <a:spcPts val="1560"/>
+              </a:lnSpc>
+              <a:spcAft>
+                <a:spcPts val="0"/>
+              </a:spcAft>
+              <a:buNone/>
+            </a:pPr>
+            <a:r>
+              <a:rPr lang="en-US" sz="1200" b="0">
+                <a:solidFill>
+                  <a:srgbClr val="202b33"/>
+                </a:solidFill>
+                <a:latin typeface="Arial"/>
+                <a:ea typeface="Arial"/>
+                <a:cs typeface="Arial"/>
+              </a:rPr>
+              <a:t xml:space="preserve">Agentic workloads do. The orchestrator knows this batch is mostly waiting on a provider, that this one needs a GPU for ninety seconds, that this one is untrusted code and wants a sandbox. It can say so, per job, at the moment the job starts.</a:t>
             </a:r>
             <a:endParaRPr lang="en-US" sz="1200"/>
           </a:p>
@@ -3653,7 +3653,7 @@
                 <a:ea typeface="Arial"/>
                 <a:cs typeface="Arial"/>
               </a:rPr>
-              <a:t xml:space="preserve">The pieces exist, and they are shaped for this. Fly.io Sprites are hardware-isolated VMs that create in a second or two, checkpoint and restore, and take an egress policy from outside so the agent inside cannot loosen it. Depot sandboxes bill per second for exactly this: run agent-generated code, stream output, throw it away.</a:t>
+              <a:t xml:space="preserve">The pieces exist, and they are shaped for this. Fly.io Sprites are microVMs whose stated creation target is under a second, checkpoint and restore, and take an egress policy from outside so the agent inside cannot loosen it. Depot sandboxes bill by the second for exactly this: run agent-generated code, throw it away.</a:t>
             </a:r>
             <a:endParaRPr lang="en-US" sz="1200"/>
           </a:p>
@@ -4226,7 +4226,7 @@
                 <a:ea typeface="Arial"/>
                 <a:cs typeface="Arial"/>
               </a:rPr>
-              <a:t xml:space="preserve">The pieces exist, and they are shaped for this. Fly.io Sprites are hardware-isolated VMs that create in a second or two, checkpoint and restore, and take an egress policy from outside so the agent inside cannot loosen it. Depot sandboxes bill per second for exactly this: run agent-generated code, stream output, throw it away.</a:t>
+              <a:t xml:space="preserve">The pieces exist, and they are shaped for this. Fly.io Sprites are microVMs whose stated creation target is under a second, checkpoint and restore, and take an egress policy from outside so the agent inside cannot loosen it. Depot sandboxes bill by the second for exactly this: run agent-generated code, throw it away.</a:t>
             </a:r>
             <a:endParaRPr lang="en-US" sz="1200"/>
           </a:p>
@@ -4937,53 +4937,53 @@
                 <a:ea typeface="Arial"/>
                 <a:cs typeface="Arial"/>
               </a:rPr>
-              <a:t xml:space="preserve">Five minutes from demo.md. Ask the room for each next transition before revealing it.</a:t>
-            </a:r>
-            <a:endParaRPr lang="en-US" sz="1200"/>
-          </a:p>
-          <a:p>
-            <a:pPr marL="0" indent="0">
-              <a:lnSpc>
-                <a:spcPts val="1560"/>
-              </a:lnSpc>
-              <a:spcAft>
-                <a:spcPts val="0"/>
-              </a:spcAft>
-              <a:buNone/>
-            </a:pPr>
-            <a:r>
-              <a:rPr lang="en-US" sz="1200" b="0">
-                <a:solidFill>
-                  <a:srgbClr val="202b33"/>
-                </a:solidFill>
-                <a:latin typeface="Arial"/>
-                <a:ea typeface="Arial"/>
-                <a:cs typeface="Arial"/>
-              </a:rPr>
-              <a:t xml:space="preserve"/>
-            </a:r>
-            <a:endParaRPr lang="en-US" sz="1200"/>
-          </a:p>
-          <a:p>
-            <a:pPr marL="0" indent="0">
-              <a:lnSpc>
-                <a:spcPts val="1560"/>
-              </a:lnSpc>
-              <a:spcAft>
-                <a:spcPts val="0"/>
-              </a:spcAft>
-              <a:buNone/>
-            </a:pPr>
-            <a:r>
-              <a:rPr lang="en-US" sz="1200" b="0">
-                <a:solidFill>
-                  <a:srgbClr val="202b33"/>
-                </a:solidFill>
-                <a:latin typeface="Arial"/>
-                <a:ea typeface="Arial"/>
-                <a:cs typeface="Arial"/>
-              </a:rPr>
-              <a:t xml:space="preserve">Bridge: attempts are a scaling axis and so is judging; a council of cheap judges from different models tells you where they disagree, and that is the candidate that gets a human. Bound the attempts, gate them, and treat any synthesis as a new candidate.</a:t>
+              <a:t xml:space="preserve">The trace in demo.md; compress rows 1 and 2 on the short routes. Ask the room for each next transition before revealing it.</a:t>
+            </a:r>
+            <a:endParaRPr lang="en-US" sz="1200"/>
+          </a:p>
+          <a:p>
+            <a:pPr marL="0" indent="0">
+              <a:lnSpc>
+                <a:spcPts val="1560"/>
+              </a:lnSpc>
+              <a:spcAft>
+                <a:spcPts val="0"/>
+              </a:spcAft>
+              <a:buNone/>
+            </a:pPr>
+            <a:r>
+              <a:rPr lang="en-US" sz="1200" b="0">
+                <a:solidFill>
+                  <a:srgbClr val="202b33"/>
+                </a:solidFill>
+                <a:latin typeface="Arial"/>
+                <a:ea typeface="Arial"/>
+                <a:cs typeface="Arial"/>
+              </a:rPr>
+              <a:t xml:space="preserve"/>
+            </a:r>
+            <a:endParaRPr lang="en-US" sz="1200"/>
+          </a:p>
+          <a:p>
+            <a:pPr marL="0" indent="0">
+              <a:lnSpc>
+                <a:spcPts val="1560"/>
+              </a:lnSpc>
+              <a:spcAft>
+                <a:spcPts val="0"/>
+              </a:spcAft>
+              <a:buNone/>
+            </a:pPr>
+            <a:r>
+              <a:rPr lang="en-US" sz="1200" b="0">
+                <a:solidFill>
+                  <a:srgbClr val="202b33"/>
+                </a:solidFill>
+                <a:latin typeface="Arial"/>
+                <a:ea typeface="Arial"/>
+                <a:cs typeface="Arial"/>
+              </a:rPr>
+              <a:t xml:space="preserve">Bridge: two more scaling axes have names. The barrel-of-monkeys maneuver leads with cheap parallel generation on purpose and hands the barrel to the next stage. The Council of Guards is cheap judges from different models, and the number you want back is the disagreement. Gate every candidate; a synthesis is a new candidate.</a:t>
             </a:r>
             <a:endParaRPr lang="en-US" sz="1200"/>
           </a:p>
@@ -7624,7 +7624,7 @@
                 <a:ea typeface="Arial"/>
                 <a:cs typeface="Arial"/>
               </a:rPr>
-              <a:t xml:space="preserve">guess. The workload never got a vote.</a:t>
+              <a:t xml:space="preserve">guess. The workload never got a say.</a:t>
             </a:r>
             <a:endParaRPr lang="en-US" sz="1200"/>
           </a:p>
@@ -7670,7 +7670,7 @@
                 <a:ea typeface="Arial"/>
                 <a:cs typeface="Arial"/>
               </a:rPr>
-              <a:t xml:space="preserve">Agentic workloads can vote. The orchestrator knows</a:t>
+              <a:t xml:space="preserve">Agentic workloads do. The orchestrator knows this</a:t>
             </a:r>
             <a:endParaRPr lang="en-US" sz="1200"/>
           </a:p>
@@ -7693,7 +7693,7 @@
                 <a:ea typeface="Arial"/>
                 <a:cs typeface="Arial"/>
               </a:rPr>
-              <a:t xml:space="preserve">this batch is mostly waiting on a provider, that this</a:t>
+              <a:t xml:space="preserve">batch is mostly waiting on a provider, that this one</a:t>
             </a:r>
             <a:endParaRPr lang="en-US" sz="1200"/>
           </a:p>
@@ -7716,7 +7716,7 @@
                 <a:ea typeface="Arial"/>
                 <a:cs typeface="Arial"/>
               </a:rPr>
-              <a:t xml:space="preserve">one needs a GPU for ninety seconds, that this one is</a:t>
+              <a:t xml:space="preserve">needs a GPU for ninety seconds, that this one is</a:t>
             </a:r>
             <a:endParaRPr lang="en-US" sz="1200"/>
           </a:p>
@@ -8764,7 +8764,7 @@
                 <a:ea typeface="Arial"/>
                 <a:cs typeface="Arial"/>
               </a:rPr>
-              <a:t xml:space="preserve">The inversion: infra as an agent capability</a:t>
+              <a:t xml:space="preserve">Infra Is a Tool Call</a:t>
             </a:r>
             <a:endParaRPr lang="en-US" sz="2550"/>
           </a:p>
@@ -9583,30 +9583,7 @@
                 <a:ea typeface="Arial"/>
                 <a:cs typeface="Arial"/>
               </a:rPr>
-              <a:t xml:space="preserve">The inversion: infra as an agent capability</a:t>
-            </a:r>
-            <a:endParaRPr lang="en-US" sz="2550"/>
-          </a:p>
-          <a:p>
-            <a:pPr marL="0" indent="0">
-              <a:lnSpc>
-                <a:spcPts val="3060"/>
-              </a:lnSpc>
-              <a:spcAft>
-                <a:spcPts val="0"/>
-              </a:spcAft>
-              <a:buNone/>
-            </a:pPr>
-            <a:r>
-              <a:rPr lang="en-US" sz="2550" b="1">
-                <a:solidFill>
-                  <a:srgbClr val="202B33"/>
-                </a:solidFill>
-                <a:latin typeface="Arial"/>
-                <a:ea typeface="Arial"/>
-                <a:cs typeface="Arial"/>
-              </a:rPr>
-              <a:t xml:space="preserve">(continued)</a:t>
+              <a:t xml:space="preserve">Infra Is a Tool Call (continued)</a:t>
             </a:r>
             <a:endParaRPr lang="en-US" sz="2550"/>
           </a:p>
@@ -10025,7 +10002,7 @@
                 <a:ea typeface="Arial"/>
                 <a:cs typeface="Arial"/>
               </a:rPr>
-              <a:t xml:space="preserve">The ecosystem is already ephemeral by default</a:t>
+              <a:t xml:space="preserve">Torn Down by Default</a:t>
             </a:r>
             <a:endParaRPr lang="en-US" sz="2550"/>
           </a:p>
@@ -10055,7 +10032,7 @@
       </p:sp>
       <p:pic>
         <p:nvPicPr>
-          <p:cNvPr id="5" name="f5c9434104cce2c1d2b93f00f44fc408290defaf280712183703c30a3c4a91dd" descr="Sandboxes, serverless GPUs, durable edge state and spot capacity, all created in seconds and torn down by default."/>
+          <p:cNvPr id="5" name="1daa0143328d8028c247af2b7cfb4a0a77c5d39818a1b12c28efc7e58b692783" descr="Sandboxes, serverless GPUs, durable edge state and spot capacity, all created in seconds and torn down by default."/>
           <p:cNvPicPr>
             <a:picLocks noChangeAspect="1"/>
           </p:cNvPicPr>
@@ -10359,7 +10336,7 @@
                 <a:ea typeface="Arial"/>
                 <a:cs typeface="Arial"/>
               </a:rPr>
-              <a:t xml:space="preserve">Fly.io Sprites are hardware-isolated VMs that create</a:t>
+              <a:t xml:space="preserve">Fly.io Sprites are microVMs whose stated creation</a:t>
             </a:r>
             <a:endParaRPr lang="en-US" sz="1200"/>
           </a:p>
@@ -10382,7 +10359,7 @@
                 <a:ea typeface="Arial"/>
                 <a:cs typeface="Arial"/>
               </a:rPr>
-              <a:t xml:space="preserve">in a second or two, checkpoint and restore, and take</a:t>
+              <a:t xml:space="preserve">target is under a second, checkpoint and restore, and</a:t>
             </a:r>
             <a:endParaRPr lang="en-US" sz="1200"/>
           </a:p>
@@ -10405,7 +10382,7 @@
                 <a:ea typeface="Arial"/>
                 <a:cs typeface="Arial"/>
               </a:rPr>
-              <a:t xml:space="preserve">an egress policy from outside so the agent inside</a:t>
+              <a:t xml:space="preserve">take an egress policy from outside so the agent</a:t>
             </a:r>
             <a:endParaRPr lang="en-US" sz="1200"/>
           </a:p>
@@ -10454,7 +10431,7 @@
                 <a:ea typeface="Arial"/>
                 <a:cs typeface="Arial"/>
               </a:rPr>
-              <a:t xml:space="preserve">cannot loosen it. Depot sandboxes bill per second for</a:t>
+              <a:t xml:space="preserve">inside cannot loosen it. Depot sandboxes bill by the</a:t>
             </a:r>
             <a:endParaRPr lang="en-US" sz="1200"/>
           </a:p>
@@ -10477,7 +10454,7 @@
                 <a:ea typeface="Arial"/>
                 <a:cs typeface="Arial"/>
               </a:rPr>
-              <a:t xml:space="preserve">exactly this: run agent-generated code, stream</a:t>
+              <a:t xml:space="preserve">second for exactly this: run agent-generated code,</a:t>
             </a:r>
             <a:endParaRPr lang="en-US" sz="1200"/>
           </a:p>
@@ -10500,7 +10477,7 @@
                 <a:ea typeface="Arial"/>
                 <a:cs typeface="Arial"/>
               </a:rPr>
-              <a:t xml:space="preserve">output, throw it away.</a:t>
+              <a:t xml:space="preserve">throw it away.</a:t>
             </a:r>
             <a:endParaRPr lang="en-US" sz="1200"/>
           </a:p>
@@ -10936,30 +10913,7 @@
                 <a:ea typeface="Arial"/>
                 <a:cs typeface="Arial"/>
               </a:rPr>
-              <a:t xml:space="preserve">The ecosystem is already ephemeral by default</a:t>
-            </a:r>
-            <a:endParaRPr lang="en-US" sz="2550"/>
-          </a:p>
-          <a:p>
-            <a:pPr marL="0" indent="0">
-              <a:lnSpc>
-                <a:spcPts val="3060"/>
-              </a:lnSpc>
-              <a:spcAft>
-                <a:spcPts val="0"/>
-              </a:spcAft>
-              <a:buNone/>
-            </a:pPr>
-            <a:r>
-              <a:rPr lang="en-US" sz="2550" b="1">
-                <a:solidFill>
-                  <a:srgbClr val="202B33"/>
-                </a:solidFill>
-                <a:latin typeface="Arial"/>
-                <a:ea typeface="Arial"/>
-                <a:cs typeface="Arial"/>
-              </a:rPr>
-              <a:t xml:space="preserve">(continued)</a:t>
+              <a:t xml:space="preserve">Torn Down by Default (continued)</a:t>
             </a:r>
             <a:endParaRPr lang="en-US" sz="2550"/>
           </a:p>

</xml_diff>